<commit_message>
added evaluate skill and quality metrics  MCP server
</commit_message>
<xml_diff>
--- a/Demo/AI-Mastery Training Capstone Project Demo.pptx
+++ b/Demo/AI-Mastery Training Capstone Project Demo.pptx
@@ -753,6 +753,13 @@
             <a:avLst/>
           </a:prstGeom>
         </p:spPr>
+        <p:txBody>
+          <a:bodyPr/>
+          <a:lstStyle/>
+          <a:p>
+            <a:endParaRPr lang="en-IN"/>
+          </a:p>
+        </p:txBody>
       </p:sp>
       <p:sp>
         <p:nvSpPr>
@@ -861,6 +868,13 @@
             <a:avLst/>
           </a:prstGeom>
         </p:spPr>
+        <p:txBody>
+          <a:bodyPr/>
+          <a:lstStyle/>
+          <a:p>
+            <a:endParaRPr lang="en-IN"/>
+          </a:p>
+        </p:txBody>
       </p:sp>
       <p:sp>
         <p:nvSpPr>
@@ -981,6 +995,13 @@
             <a:avLst/>
           </a:prstGeom>
         </p:spPr>
+        <p:txBody>
+          <a:bodyPr/>
+          <a:lstStyle/>
+          <a:p>
+            <a:endParaRPr lang="en-IN"/>
+          </a:p>
+        </p:txBody>
       </p:sp>
       <p:sp>
         <p:nvSpPr>
@@ -1113,6 +1134,13 @@
             <a:avLst/>
           </a:prstGeom>
         </p:spPr>
+        <p:txBody>
+          <a:bodyPr/>
+          <a:lstStyle/>
+          <a:p>
+            <a:endParaRPr lang="en-IN"/>
+          </a:p>
+        </p:txBody>
       </p:sp>
       <p:sp>
         <p:nvSpPr>
@@ -1245,6 +1273,13 @@
             <a:avLst/>
           </a:prstGeom>
         </p:spPr>
+        <p:txBody>
+          <a:bodyPr/>
+          <a:lstStyle/>
+          <a:p>
+            <a:endParaRPr lang="en-IN"/>
+          </a:p>
+        </p:txBody>
       </p:sp>
       <p:sp>
         <p:nvSpPr>
@@ -1365,6 +1400,13 @@
             <a:avLst/>
           </a:prstGeom>
         </p:spPr>
+        <p:txBody>
+          <a:bodyPr/>
+          <a:lstStyle/>
+          <a:p>
+            <a:endParaRPr lang="en-IN"/>
+          </a:p>
+        </p:txBody>
       </p:sp>
       <p:sp>
         <p:nvSpPr>
@@ -12104,12 +12146,8 @@
               <a:buChar char="•"/>
             </a:pPr>
             <a:r>
-              <a:rPr lang="en-IN" sz="1600" b="1" dirty="0" err="1"/>
-              <a:t>tickets.json</a:t>
-            </a:r>
-            <a:r>
               <a:rPr lang="en-IN" sz="1600" b="1" dirty="0"/>
-              <a:t> – </a:t>
+              <a:t>tickets.json – </a:t>
             </a:r>
             <a:r>
               <a:rPr lang="en-IN" sz="1600" dirty="0"/>
@@ -12132,7 +12170,11 @@
             </a:r>
             <a:r>
               <a:rPr lang="en-IN" dirty="0"/>
-              <a:t>riting rules for each issue type (New Feature, Enhancement)</a:t>
+              <a:t>riting rules for each issue type (New Feature</a:t>
+            </a:r>
+            <a:r>
+              <a:rPr lang="en-IN"/>
+              <a:t>, Enhancement, Bug)</a:t>
             </a:r>
             <a:r>
               <a:rPr lang="en-IN" sz="1600" dirty="0"/>
@@ -14623,6 +14665,26 @@
 </file>
 
 <file path=customXml/item1.xml><?xml version="1.0" encoding="utf-8"?>
+<p:properties xmlns:p="http://schemas.microsoft.com/office/2006/metadata/properties" xmlns:xsi="http://www.w3.org/2001/XMLSchema-instance" xmlns:pc="http://schemas.microsoft.com/office/infopath/2007/PartnerControls">
+  <documentManagement>
+    <_ip_UnifiedCompliancePolicyUIAction xmlns="http://schemas.microsoft.com/sharepoint/v3" xsi:nil="true"/>
+    <Image xmlns="71af3243-3dd4-4a8d-8c0d-dd76da1f02a5">
+      <Url xsi:nil="true"/>
+      <Description xsi:nil="true"/>
+    </Image>
+    <Status xmlns="71af3243-3dd4-4a8d-8c0d-dd76da1f02a5">Not started</Status>
+    <Background xmlns="71af3243-3dd4-4a8d-8c0d-dd76da1f02a5">false</Background>
+    <_ip_UnifiedCompliancePolicyProperties xmlns="http://schemas.microsoft.com/sharepoint/v3" xsi:nil="true"/>
+    <ImageTagsTaxHTField xmlns="71af3243-3dd4-4a8d-8c0d-dd76da1f02a5">
+      <Terms xmlns="http://schemas.microsoft.com/office/infopath/2007/PartnerControls"/>
+    </ImageTagsTaxHTField>
+    <TaxCatchAll xmlns="230e9df3-be65-4c73-a93b-d1236ebd677e" xsi:nil="true"/>
+    <MediaServiceKeyPoints xmlns="71af3243-3dd4-4a8d-8c0d-dd76da1f02a5" xsi:nil="true"/>
+  </documentManagement>
+</p:properties>
+</file>
+
+<file path=customXml/item2.xml><?xml version="1.0" encoding="utf-8"?>
 <ct:contentTypeSchema xmlns:ct="http://schemas.microsoft.com/office/2006/metadata/contentType" xmlns:ma="http://schemas.microsoft.com/office/2006/metadata/properties/metaAttributes" ct:_="" ma:_="" ma:contentTypeName="Document" ma:contentTypeID="0x01010079F111ED35F8CC479449609E8A0923A6" ma:contentTypeVersion="30" ma:contentTypeDescription="Create a new document." ma:contentTypeScope="" ma:versionID="cec0622158e8f13124e9e8fd4de31bd1">
   <xsd:schema xmlns:xsd="http://www.w3.org/2001/XMLSchema" xmlns:xs="http://www.w3.org/2001/XMLSchema" xmlns:p="http://schemas.microsoft.com/office/2006/metadata/properties" xmlns:ns1="http://schemas.microsoft.com/sharepoint/v3" xmlns:ns2="71af3243-3dd4-4a8d-8c0d-dd76da1f02a5" xmlns:ns3="16c05727-aa75-4e4a-9b5f-8a80a1165891" xmlns:ns4="230e9df3-be65-4c73-a93b-d1236ebd677e" targetNamespace="http://schemas.microsoft.com/office/2006/metadata/properties" ma:root="true" ma:fieldsID="3b52f30ab005d15df08657af532e6e38" ns1:_="" ns2:_="" ns3:_="" ns4:_="">
     <xsd:import namespace="http://schemas.microsoft.com/sharepoint/v3"/>
@@ -14940,26 +15002,6 @@
 </ct:contentTypeSchema>
 </file>
 
-<file path=customXml/item2.xml><?xml version="1.0" encoding="utf-8"?>
-<p:properties xmlns:p="http://schemas.microsoft.com/office/2006/metadata/properties" xmlns:xsi="http://www.w3.org/2001/XMLSchema-instance" xmlns:pc="http://schemas.microsoft.com/office/infopath/2007/PartnerControls">
-  <documentManagement>
-    <_ip_UnifiedCompliancePolicyUIAction xmlns="http://schemas.microsoft.com/sharepoint/v3" xsi:nil="true"/>
-    <Image xmlns="71af3243-3dd4-4a8d-8c0d-dd76da1f02a5">
-      <Url xsi:nil="true"/>
-      <Description xsi:nil="true"/>
-    </Image>
-    <Status xmlns="71af3243-3dd4-4a8d-8c0d-dd76da1f02a5">Not started</Status>
-    <Background xmlns="71af3243-3dd4-4a8d-8c0d-dd76da1f02a5">false</Background>
-    <_ip_UnifiedCompliancePolicyProperties xmlns="http://schemas.microsoft.com/sharepoint/v3" xsi:nil="true"/>
-    <ImageTagsTaxHTField xmlns="71af3243-3dd4-4a8d-8c0d-dd76da1f02a5">
-      <Terms xmlns="http://schemas.microsoft.com/office/infopath/2007/PartnerControls"/>
-    </ImageTagsTaxHTField>
-    <TaxCatchAll xmlns="230e9df3-be65-4c73-a93b-d1236ebd677e" xsi:nil="true"/>
-    <MediaServiceKeyPoints xmlns="71af3243-3dd4-4a8d-8c0d-dd76da1f02a5" xsi:nil="true"/>
-  </documentManagement>
-</p:properties>
-</file>
-
 <file path=customXml/item3.xml><?xml version="1.0" encoding="utf-8"?>
 <?mso-contentType ?>
 <FormTemplates xmlns="http://schemas.microsoft.com/sharepoint/v3/contenttype/forms">
@@ -14970,6 +15012,18 @@
 </file>
 
 <file path=customXml/itemProps1.xml><?xml version="1.0" encoding="utf-8"?>
+<ds:datastoreItem xmlns:ds="http://schemas.openxmlformats.org/officeDocument/2006/customXml" ds:itemID="{C8DB3C62-858A-4A01-AFEF-21E0BB8CE262}">
+  <ds:schemaRefs>
+    <ds:schemaRef ds:uri="http://schemas.microsoft.com/office/2006/metadata/properties"/>
+    <ds:schemaRef ds:uri="http://schemas.microsoft.com/office/infopath/2007/PartnerControls"/>
+    <ds:schemaRef ds:uri="http://schemas.microsoft.com/sharepoint/v3"/>
+    <ds:schemaRef ds:uri="71af3243-3dd4-4a8d-8c0d-dd76da1f02a5"/>
+    <ds:schemaRef ds:uri="230e9df3-be65-4c73-a93b-d1236ebd677e"/>
+  </ds:schemaRefs>
+</ds:datastoreItem>
+</file>
+
+<file path=customXml/itemProps2.xml><?xml version="1.0" encoding="utf-8"?>
 <ds:datastoreItem xmlns:ds="http://schemas.openxmlformats.org/officeDocument/2006/customXml" ds:itemID="{79897CAE-455D-42C9-A951-0C21BC122543}">
   <ds:schemaRefs>
     <ds:schemaRef ds:uri="http://schemas.microsoft.com/office/2006/metadata/contentType"/>
@@ -14990,18 +15044,6 @@
 </ds:datastoreItem>
 </file>
 
-<file path=customXml/itemProps2.xml><?xml version="1.0" encoding="utf-8"?>
-<ds:datastoreItem xmlns:ds="http://schemas.openxmlformats.org/officeDocument/2006/customXml" ds:itemID="{C8DB3C62-858A-4A01-AFEF-21E0BB8CE262}">
-  <ds:schemaRefs>
-    <ds:schemaRef ds:uri="http://schemas.microsoft.com/office/2006/metadata/properties"/>
-    <ds:schemaRef ds:uri="http://schemas.microsoft.com/office/infopath/2007/PartnerControls"/>
-    <ds:schemaRef ds:uri="http://schemas.microsoft.com/sharepoint/v3"/>
-    <ds:schemaRef ds:uri="71af3243-3dd4-4a8d-8c0d-dd76da1f02a5"/>
-    <ds:schemaRef ds:uri="230e9df3-be65-4c73-a93b-d1236ebd677e"/>
-  </ds:schemaRefs>
-</ds:datastoreItem>
-</file>
-
 <file path=customXml/itemProps3.xml><?xml version="1.0" encoding="utf-8"?>
 <ds:datastoreItem xmlns:ds="http://schemas.openxmlformats.org/officeDocument/2006/customXml" ds:itemID="{B0009351-EDD4-484E-ACD6-D50CCB137637}">
   <ds:schemaRefs>

</xml_diff>

<commit_message>
updated skill and demo ppt file
</commit_message>
<xml_diff>
--- a/Demo/AI-Mastery Training Capstone Project Demo.pptx
+++ b/Demo/AI-Mastery Training Capstone Project Demo.pptx
@@ -237,7 +237,7 @@
           <a:p>
             <a:fld id="{8CD26A2A-0A96-0647-84E5-C82F2EFD9474}" type="datetimeFigureOut">
               <a:rPr lang="en-US" smtClean="0"/>
-              <a:t>10/2/2026</a:t>
+              <a:t>10/3/2026</a:t>
             </a:fld>
             <a:endParaRPr lang="en-US" dirty="0"/>
           </a:p>
@@ -502,7 +502,7 @@
           <a:p>
             <a:fld id="{5B0CF20C-6BCC-41A4-8C16-5A346425718D}" type="datetimeFigureOut">
               <a:rPr lang="en-US" smtClean="0"/>
-              <a:t>10/2/2026</a:t>
+              <a:t>10/3/2026</a:t>
             </a:fld>
             <a:endParaRPr lang="en-US" dirty="0"/>
           </a:p>
@@ -784,6 +784,18 @@
           <a:bodyPr/>
           <a:lstStyle/>
           <a:p>
+            <a:r>
+              <a:rPr lang="en-IN" sz="1200" b="0" i="0" kern="1200" dirty="0">
+                <a:solidFill>
+                  <a:schemeClr val="tx1"/>
+                </a:solidFill>
+                <a:effectLst/>
+                <a:latin typeface="+mn-lt"/>
+                <a:ea typeface="+mn-ea"/>
+                <a:cs typeface="+mn-cs"/>
+              </a:rPr>
+              <a:t>Release notes are a critical touchpoint between product teams and users, yet they remain one of the most manual, time-consuming, and inconsistent parts of the release process. Technical writers spend hours translating dense developer tickets into user-friendly language, often working under tight deadlines that lead to delayed communication, inconsistent tone, and content that can sometimes fails to resonate with end users. To solve this problem I have created release note generator that will generate the release notes based on predefined style guides and evaluate the content based on defined quality metric providing scores and recommendations for improvements.</a:t>
+            </a:r>
             <a:endParaRPr lang="en-US" dirty="0"/>
           </a:p>
         </p:txBody>
@@ -11210,17 +11222,29 @@
         </p:nvSpPr>
         <p:spPr>
           <a:xfrm>
-            <a:off x="1144292" y="731520"/>
-            <a:ext cx="5029200" cy="3291840"/>
+            <a:off x="153097" y="209862"/>
+            <a:ext cx="7368034" cy="2659254"/>
           </a:xfrm>
         </p:spPr>
         <p:txBody>
-          <a:bodyPr lIns="0" anchor="b" anchorCtr="0"/>
+          <a:bodyPr lIns="0" anchor="b" anchorCtr="0">
+            <a:normAutofit/>
+          </a:bodyPr>
           <a:lstStyle/>
           <a:p>
             <a:r>
               <a:rPr lang="en-US" altLang="zh-CN" dirty="0"/>
-              <a:t>AI-Mastery Training Capstone Project Demo</a:t>
+              <a:t>Capstone Project Demo </a:t>
+            </a:r>
+            <a:br>
+              <a:rPr lang="en-US" altLang="zh-CN" dirty="0"/>
+            </a:br>
+            <a:br>
+              <a:rPr lang="en-US" altLang="zh-CN" dirty="0"/>
+            </a:br>
+            <a:r>
+              <a:rPr lang="en-US" altLang="zh-CN" sz="3200" dirty="0"/>
+              <a:t>Release Notes Generator</a:t>
             </a:r>
             <a:endParaRPr lang="en-US" dirty="0"/>
           </a:p>
@@ -11335,7 +11359,7 @@
         </p:nvSpPr>
         <p:spPr>
           <a:xfrm>
-            <a:off x="-47961" y="206265"/>
+            <a:off x="-47961" y="116325"/>
             <a:ext cx="7132320" cy="693145"/>
           </a:xfrm>
         </p:spPr>
@@ -11374,7 +11398,7 @@
         </p:nvSpPr>
         <p:spPr>
           <a:xfrm>
-            <a:off x="59968" y="1023827"/>
+            <a:off x="59968" y="933887"/>
             <a:ext cx="7375161" cy="2094127"/>
           </a:xfrm>
         </p:spPr>
@@ -11386,7 +11410,7 @@
           <a:p>
             <a:r>
               <a:rPr lang="en-US" sz="1600" b="1" dirty="0"/>
-              <a:t>Release notes generation is a manual, time-consuming bottleneck that produces inconsistent results.</a:t>
+              <a:t>Release notes generation is a manual, time-consuming bottleneck that can produce inconsistent results.</a:t>
             </a:r>
           </a:p>
           <a:p>
@@ -11650,7 +11674,7 @@
         </p:nvSpPr>
         <p:spPr>
           <a:xfrm>
-            <a:off x="59968" y="2874370"/>
+            <a:off x="59968" y="2784430"/>
             <a:ext cx="7132320" cy="693145"/>
           </a:xfrm>
           <a:prstGeom prst="rect">
@@ -11708,7 +11732,7 @@
         </p:nvSpPr>
         <p:spPr>
           <a:xfrm>
-            <a:off x="167897" y="3691932"/>
+            <a:off x="167897" y="3601992"/>
             <a:ext cx="7375161" cy="310448"/>
           </a:xfrm>
           <a:prstGeom prst="rect">
@@ -11907,7 +11931,7 @@
         </p:nvSpPr>
         <p:spPr>
           <a:xfrm>
-            <a:off x="59968" y="3740047"/>
+            <a:off x="59968" y="3650107"/>
             <a:ext cx="7132320" cy="693145"/>
           </a:xfrm>
           <a:prstGeom prst="rect">
@@ -11965,7 +11989,7 @@
         </p:nvSpPr>
         <p:spPr>
           <a:xfrm>
-            <a:off x="167896" y="4557609"/>
+            <a:off x="59968" y="4286890"/>
             <a:ext cx="8511409" cy="1393486"/>
           </a:xfrm>
           <a:prstGeom prst="rect">
@@ -12165,20 +12189,30 @@
               <a:buChar char="•"/>
             </a:pPr>
             <a:r>
+              <a:rPr lang="en-IN" sz="1600" b="1" dirty="0"/>
+              <a:t>MCP Servers </a:t>
+            </a:r>
+            <a:r>
               <a:rPr lang="en-IN" sz="1600" dirty="0"/>
-              <a:t>Style Guide MCP Server – Provides w</a:t>
+              <a:t>– For this demo, I have created following two MCP servers:</a:t>
+            </a:r>
+          </a:p>
+          <a:p>
+            <a:pPr marL="633222" lvl="1" indent="-285750"/>
+            <a:r>
+              <a:rPr lang="en-IN" sz="1600" dirty="0"/>
+              <a:t>Style Guide Server - Provides w</a:t>
             </a:r>
             <a:r>
               <a:rPr lang="en-IN" dirty="0"/>
-              <a:t>riting rules for each issue type (New Feature</a:t>
+              <a:t>riting rules for each issue type (New Feature, Enhancement, Bug)</a:t>
             </a:r>
-            <a:r>
-              <a:rPr lang="en-IN"/>
-              <a:t>, Enhancement, Bug)</a:t>
-            </a:r>
+          </a:p>
+          <a:p>
+            <a:pPr marL="633222" lvl="1" indent="-285750"/>
             <a:r>
               <a:rPr lang="en-IN" sz="1600" dirty="0"/>
-              <a:t>	 </a:t>
+              <a:t>Quality Metrics Server – Evaluate the output file based on  the  defined quality metrics and generates a report for the tech writers. It provides scores based on defined content quality metric and suggestions/recommendations for improvements.	 </a:t>
             </a:r>
             <a:endParaRPr lang="en-US" sz="1600" dirty="0"/>
           </a:p>
@@ -12238,7 +12272,7 @@
         </p:nvSpPr>
         <p:spPr>
           <a:xfrm>
-            <a:off x="-47961" y="206265"/>
+            <a:off x="-47961" y="11395"/>
             <a:ext cx="7132320" cy="693145"/>
           </a:xfrm>
         </p:spPr>
@@ -12277,13 +12311,13 @@
         </p:nvSpPr>
         <p:spPr>
           <a:xfrm>
-            <a:off x="59968" y="1023828"/>
-            <a:ext cx="7375161" cy="1295314"/>
+            <a:off x="59967" y="828958"/>
+            <a:ext cx="8859181" cy="2004184"/>
           </a:xfrm>
         </p:spPr>
         <p:txBody>
           <a:bodyPr>
-            <a:normAutofit/>
+            <a:normAutofit fontScale="92500" lnSpcReduction="20000"/>
           </a:bodyPr>
           <a:lstStyle/>
           <a:p>
@@ -12298,8 +12332,8 @@
               <a:buChar char="•"/>
             </a:pPr>
             <a:r>
-              <a:rPr lang="en-US" sz="1600" dirty="0"/>
-              <a:t>Release notes organized by issue type (New Features, Enhancements).</a:t>
+              <a:rPr lang="en-US" sz="1700" dirty="0"/>
+              <a:t>Release notes organized by issue type (New Features, Enhancements, Bug Fixes).</a:t>
             </a:r>
           </a:p>
           <a:p>
@@ -12308,8 +12342,28 @@
               <a:buChar char="•"/>
             </a:pPr>
             <a:r>
-              <a:rPr lang="en-US" sz="1600" dirty="0"/>
+              <a:rPr lang="en-US" sz="1700" dirty="0"/>
+              <a:t>Captures the significant release benefits and generate a Release Highlights.</a:t>
+            </a:r>
+          </a:p>
+          <a:p>
+            <a:pPr marL="285750" indent="-285750">
+              <a:buFont typeface="Arial" panose="020B0604020202020204" pitchFamily="34" charset="0"/>
+              <a:buChar char="•"/>
+            </a:pPr>
+            <a:r>
+              <a:rPr lang="en-US" sz="1700" dirty="0"/>
               <a:t>Strict adherence to the company's style guide for each section.</a:t>
+            </a:r>
+          </a:p>
+          <a:p>
+            <a:pPr marL="285750" indent="-285750">
+              <a:buFont typeface="Arial" panose="020B0604020202020204" pitchFamily="34" charset="0"/>
+              <a:buChar char="•"/>
+            </a:pPr>
+            <a:r>
+              <a:rPr lang="en-US" sz="1700" dirty="0"/>
+              <a:t>Evaluate and generate a quality report for tech writers to view and decide the area of improvement with assistance through recommendations.</a:t>
             </a:r>
           </a:p>
         </p:txBody>
@@ -12543,7 +12597,7 @@
         </p:nvSpPr>
         <p:spPr>
           <a:xfrm>
-            <a:off x="59968" y="2019933"/>
+            <a:off x="59968" y="2499613"/>
             <a:ext cx="7132320" cy="693145"/>
           </a:xfrm>
           <a:prstGeom prst="rect">
@@ -12601,7 +12655,7 @@
         </p:nvSpPr>
         <p:spPr>
           <a:xfrm>
-            <a:off x="167897" y="2837495"/>
+            <a:off x="167897" y="3317175"/>
             <a:ext cx="7375161" cy="1393486"/>
           </a:xfrm>
           <a:prstGeom prst="rect">
@@ -12823,7 +12877,7 @@
         </p:nvSpPr>
         <p:spPr>
           <a:xfrm>
-            <a:off x="59968" y="4054841"/>
+            <a:off x="59968" y="4384621"/>
             <a:ext cx="7132320" cy="693145"/>
           </a:xfrm>
           <a:prstGeom prst="rect">
@@ -12881,7 +12935,7 @@
         </p:nvSpPr>
         <p:spPr>
           <a:xfrm>
-            <a:off x="167896" y="4872403"/>
+            <a:off x="167896" y="5172203"/>
             <a:ext cx="8511409" cy="1393486"/>
           </a:xfrm>
           <a:prstGeom prst="rect">
@@ -13097,6 +13151,16 @@
               <a:rPr lang="en-US" sz="1600" dirty="0"/>
               <a:t>100% adherence to style guide rules across all issue types.</a:t>
             </a:r>
+          </a:p>
+          <a:p>
+            <a:pPr marL="285750" indent="-285750">
+              <a:buFont typeface="Arial" panose="020B0604020202020204" pitchFamily="34" charset="0"/>
+              <a:buChar char="•"/>
+            </a:pPr>
+            <a:r>
+              <a:rPr lang="en-US" sz="1600" dirty="0"/>
+              <a:t>Readability – No technical jargons and easy to read and understand for end users.</a:t>
+            </a:r>
             <a:r>
               <a:rPr lang="en-IN" sz="1600" dirty="0"/>
               <a:t>	 </a:t>
@@ -13463,7 +13527,7 @@
             </a:pPr>
             <a:r>
               <a:rPr lang="en-US" sz="2000" dirty="0"/>
-              <a:t>Workshop Learnings and Repo</a:t>
+              <a:t>Workshop Learnings</a:t>
             </a:r>
           </a:p>
         </p:txBody>
@@ -13502,7 +13566,7 @@
             </a:pPr>
             <a:r>
               <a:rPr lang="en-US" sz="1600" dirty="0"/>
-              <a:t>Created a skill file based on RTCCO framework to generate the release notes.</a:t>
+              <a:t>Created a skill file based on RTCCO framework to generate the release notes and evaluate the content quality.</a:t>
             </a:r>
           </a:p>
           <a:p>
@@ -13534,27 +13598,7 @@
             </a:pPr>
             <a:r>
               <a:rPr lang="en-US" sz="1600" dirty="0"/>
-              <a:t>Created a MCP server  for style guide that help the gent to generate the content based on specific writing rules mentioned in the MCP server.</a:t>
-            </a:r>
-          </a:p>
-          <a:p>
-            <a:pPr marL="285750" indent="-285750">
-              <a:buFont typeface="Arial" panose="020B0604020202020204" pitchFamily="34" charset="0"/>
-              <a:buChar char="•"/>
-            </a:pPr>
-            <a:r>
-              <a:rPr lang="en-US" sz="1600" dirty="0"/>
-              <a:t>GitHub link: </a:t>
-            </a:r>
-            <a:r>
-              <a:rPr lang="en-US" sz="1600" dirty="0">
-                <a:hlinkClick r:id="rId3"/>
-              </a:rPr>
-              <a:t>https://github.com/RCG1412/ai-release-notes-demo.git</a:t>
-            </a:r>
-            <a:r>
-              <a:rPr lang="en-US" sz="1600" dirty="0"/>
-              <a:t> </a:t>
+              <a:t>Created a MCP server for style guide that helps to generate the content based on specific writing rules mentioned in the MCP server and for quality metric providing the report for letting the tech writer gauge the quality of content and area of improvements based on recommendation provided in the report.</a:t>
             </a:r>
           </a:p>
         </p:txBody>
@@ -13769,6 +13813,277 @@
               <a:t>5</a:t>
             </a:fld>
             <a:endParaRPr lang="en-US" altLang="zh-CN" noProof="0" dirty="0"/>
+          </a:p>
+        </p:txBody>
+      </p:sp>
+      <p:sp>
+        <p:nvSpPr>
+          <p:cNvPr id="3" name="Text Placeholder 42">
+            <a:extLst>
+              <a:ext uri="{FF2B5EF4-FFF2-40B4-BE49-F238E27FC236}">
+                <a16:creationId xmlns:a16="http://schemas.microsoft.com/office/drawing/2014/main" id="{8497FDB0-B667-30C5-8841-0C5279AB9A6E}"/>
+              </a:ext>
+            </a:extLst>
+          </p:cNvPr>
+          <p:cNvSpPr txBox="1">
+            <a:spLocks/>
+          </p:cNvSpPr>
+          <p:nvPr/>
+        </p:nvSpPr>
+        <p:spPr>
+          <a:xfrm>
+            <a:off x="59968" y="4334081"/>
+            <a:ext cx="8169632" cy="492752"/>
+          </a:xfrm>
+          <a:prstGeom prst="rect">
+            <a:avLst/>
+          </a:prstGeom>
+        </p:spPr>
+        <p:txBody>
+          <a:bodyPr vert="horz" lIns="91440" tIns="45720" rIns="91440" bIns="45720" rtlCol="0">
+            <a:normAutofit/>
+          </a:bodyPr>
+          <a:lstStyle>
+            <a:lvl1pPr marL="0" indent="0" algn="l" defTabSz="914400" rtl="0" eaLnBrk="1" latinLnBrk="0" hangingPunct="1">
+              <a:lnSpc>
+                <a:spcPct val="90000"/>
+              </a:lnSpc>
+              <a:spcBef>
+                <a:spcPts val="1500"/>
+              </a:spcBef>
+              <a:buFont typeface="Arial" panose="020B0604020202020204" pitchFamily="34" charset="0"/>
+              <a:buNone/>
+              <a:defRPr sz="1800" kern="1200">
+                <a:solidFill>
+                  <a:schemeClr val="bg1"/>
+                </a:solidFill>
+                <a:latin typeface="+mn-lt"/>
+                <a:ea typeface="+mn-ea"/>
+                <a:cs typeface="+mn-cs"/>
+              </a:defRPr>
+            </a:lvl1pPr>
+            <a:lvl2pPr marL="347472" indent="-347472" algn="l" defTabSz="914400" rtl="0" eaLnBrk="1" latinLnBrk="0" hangingPunct="1">
+              <a:lnSpc>
+                <a:spcPct val="90000"/>
+              </a:lnSpc>
+              <a:spcBef>
+                <a:spcPts val="1500"/>
+              </a:spcBef>
+              <a:buFont typeface="Arial" panose="020B0604020202020204" pitchFamily="34" charset="0"/>
+              <a:buChar char="•"/>
+              <a:defRPr sz="1800" kern="1200">
+                <a:solidFill>
+                  <a:schemeClr val="bg1"/>
+                </a:solidFill>
+                <a:latin typeface="+mn-lt"/>
+                <a:ea typeface="+mn-ea"/>
+                <a:cs typeface="+mn-cs"/>
+              </a:defRPr>
+            </a:lvl2pPr>
+            <a:lvl3pPr marL="731520" indent="-347472" algn="l" defTabSz="914400" rtl="0" eaLnBrk="1" latinLnBrk="0" hangingPunct="1">
+              <a:lnSpc>
+                <a:spcPct val="90000"/>
+              </a:lnSpc>
+              <a:spcBef>
+                <a:spcPts val="1500"/>
+              </a:spcBef>
+              <a:buFont typeface="Arial" panose="020B0604020202020204" pitchFamily="34" charset="0"/>
+              <a:buChar char="•"/>
+              <a:defRPr sz="1800" kern="1200">
+                <a:solidFill>
+                  <a:schemeClr val="bg1"/>
+                </a:solidFill>
+                <a:latin typeface="+mn-lt"/>
+                <a:ea typeface="+mn-ea"/>
+                <a:cs typeface="+mn-cs"/>
+              </a:defRPr>
+            </a:lvl3pPr>
+            <a:lvl4pPr marL="1097280" indent="-347472" algn="l" defTabSz="914400" rtl="0" eaLnBrk="1" latinLnBrk="0" hangingPunct="1">
+              <a:lnSpc>
+                <a:spcPct val="90000"/>
+              </a:lnSpc>
+              <a:spcBef>
+                <a:spcPts val="1500"/>
+              </a:spcBef>
+              <a:buFont typeface="Arial" panose="020B0604020202020204" pitchFamily="34" charset="0"/>
+              <a:buChar char="•"/>
+              <a:defRPr sz="1800" kern="1200">
+                <a:solidFill>
+                  <a:schemeClr val="bg1"/>
+                </a:solidFill>
+                <a:latin typeface="+mn-lt"/>
+                <a:ea typeface="+mn-ea"/>
+                <a:cs typeface="+mn-cs"/>
+              </a:defRPr>
+            </a:lvl4pPr>
+            <a:lvl5pPr marL="1828800" indent="-347472" algn="l" defTabSz="914400" rtl="0" eaLnBrk="1" latinLnBrk="0" hangingPunct="1">
+              <a:lnSpc>
+                <a:spcPct val="90000"/>
+              </a:lnSpc>
+              <a:spcBef>
+                <a:spcPts val="1500"/>
+              </a:spcBef>
+              <a:buFont typeface="Arial" panose="020B0604020202020204" pitchFamily="34" charset="0"/>
+              <a:buChar char="•"/>
+              <a:defRPr sz="1800" kern="1200">
+                <a:solidFill>
+                  <a:schemeClr val="bg1"/>
+                </a:solidFill>
+                <a:latin typeface="+mn-lt"/>
+                <a:ea typeface="+mn-ea"/>
+                <a:cs typeface="+mn-cs"/>
+              </a:defRPr>
+            </a:lvl5pPr>
+            <a:lvl6pPr marL="2514600" indent="-228600" algn="l" defTabSz="914400" rtl="0" eaLnBrk="1" latinLnBrk="0" hangingPunct="1">
+              <a:lnSpc>
+                <a:spcPct val="90000"/>
+              </a:lnSpc>
+              <a:spcBef>
+                <a:spcPts val="500"/>
+              </a:spcBef>
+              <a:buFont typeface="Arial" panose="020B0604020202020204" pitchFamily="34" charset="0"/>
+              <a:buChar char="•"/>
+              <a:defRPr sz="1800" kern="1200">
+                <a:solidFill>
+                  <a:schemeClr val="tx1"/>
+                </a:solidFill>
+                <a:latin typeface="+mn-lt"/>
+                <a:ea typeface="+mn-ea"/>
+                <a:cs typeface="+mn-cs"/>
+              </a:defRPr>
+            </a:lvl6pPr>
+            <a:lvl7pPr marL="2971800" indent="-228600" algn="l" defTabSz="914400" rtl="0" eaLnBrk="1" latinLnBrk="0" hangingPunct="1">
+              <a:lnSpc>
+                <a:spcPct val="90000"/>
+              </a:lnSpc>
+              <a:spcBef>
+                <a:spcPts val="500"/>
+              </a:spcBef>
+              <a:buFont typeface="Arial" panose="020B0604020202020204" pitchFamily="34" charset="0"/>
+              <a:buChar char="•"/>
+              <a:defRPr sz="1800" kern="1200">
+                <a:solidFill>
+                  <a:schemeClr val="tx1"/>
+                </a:solidFill>
+                <a:latin typeface="+mn-lt"/>
+                <a:ea typeface="+mn-ea"/>
+                <a:cs typeface="+mn-cs"/>
+              </a:defRPr>
+            </a:lvl7pPr>
+            <a:lvl8pPr marL="3429000" indent="-228600" algn="l" defTabSz="914400" rtl="0" eaLnBrk="1" latinLnBrk="0" hangingPunct="1">
+              <a:lnSpc>
+                <a:spcPct val="90000"/>
+              </a:lnSpc>
+              <a:spcBef>
+                <a:spcPts val="500"/>
+              </a:spcBef>
+              <a:buFont typeface="Arial" panose="020B0604020202020204" pitchFamily="34" charset="0"/>
+              <a:buChar char="•"/>
+              <a:defRPr sz="1800" kern="1200">
+                <a:solidFill>
+                  <a:schemeClr val="tx1"/>
+                </a:solidFill>
+                <a:latin typeface="+mn-lt"/>
+                <a:ea typeface="+mn-ea"/>
+                <a:cs typeface="+mn-cs"/>
+              </a:defRPr>
+            </a:lvl8pPr>
+            <a:lvl9pPr marL="3886200" indent="-228600" algn="l" defTabSz="914400" rtl="0" eaLnBrk="1" latinLnBrk="0" hangingPunct="1">
+              <a:lnSpc>
+                <a:spcPct val="90000"/>
+              </a:lnSpc>
+              <a:spcBef>
+                <a:spcPts val="500"/>
+              </a:spcBef>
+              <a:buFont typeface="Arial" panose="020B0604020202020204" pitchFamily="34" charset="0"/>
+              <a:buChar char="•"/>
+              <a:defRPr sz="1800" kern="1200">
+                <a:solidFill>
+                  <a:schemeClr val="tx1"/>
+                </a:solidFill>
+                <a:latin typeface="+mn-lt"/>
+                <a:ea typeface="+mn-ea"/>
+                <a:cs typeface="+mn-cs"/>
+              </a:defRPr>
+            </a:lvl9pPr>
+          </a:lstStyle>
+          <a:p>
+            <a:pPr marL="285750" indent="-285750">
+              <a:buFont typeface="Arial" panose="020B0604020202020204" pitchFamily="34" charset="0"/>
+              <a:buChar char="•"/>
+            </a:pPr>
+            <a:r>
+              <a:rPr lang="en-US" sz="1600" dirty="0"/>
+              <a:t>GitHub link: </a:t>
+            </a:r>
+            <a:r>
+              <a:rPr lang="en-US" sz="1600" dirty="0">
+                <a:hlinkClick r:id="rId3"/>
+              </a:rPr>
+              <a:t>https://github.com/RCG1412/ai-release-notes-demo.git</a:t>
+            </a:r>
+            <a:r>
+              <a:rPr lang="en-US" sz="1600" dirty="0"/>
+              <a:t> </a:t>
+            </a:r>
+          </a:p>
+        </p:txBody>
+      </p:sp>
+      <p:sp>
+        <p:nvSpPr>
+          <p:cNvPr id="4" name="Title 59">
+            <a:extLst>
+              <a:ext uri="{FF2B5EF4-FFF2-40B4-BE49-F238E27FC236}">
+                <a16:creationId xmlns:a16="http://schemas.microsoft.com/office/drawing/2014/main" id="{CF2F132A-61C7-7584-3ECD-258DAE2DDF6E}"/>
+              </a:ext>
+            </a:extLst>
+          </p:cNvPr>
+          <p:cNvSpPr txBox="1">
+            <a:spLocks/>
+          </p:cNvSpPr>
+          <p:nvPr/>
+        </p:nvSpPr>
+        <p:spPr>
+          <a:xfrm>
+            <a:off x="-47961" y="3463477"/>
+            <a:ext cx="7132320" cy="693145"/>
+          </a:xfrm>
+          <a:prstGeom prst="rect">
+            <a:avLst/>
+          </a:prstGeom>
+        </p:spPr>
+        <p:txBody>
+          <a:bodyPr vert="horz" lIns="91440" tIns="45720" rIns="91440" bIns="45720" rtlCol="0" anchor="b">
+            <a:normAutofit/>
+          </a:bodyPr>
+          <a:lstStyle>
+            <a:lvl1pPr algn="l" defTabSz="914400" rtl="0" eaLnBrk="1" latinLnBrk="0" hangingPunct="1">
+              <a:lnSpc>
+                <a:spcPct val="90000"/>
+              </a:lnSpc>
+              <a:spcBef>
+                <a:spcPct val="0"/>
+              </a:spcBef>
+              <a:buNone/>
+              <a:defRPr sz="3600" b="1" kern="1200">
+                <a:solidFill>
+                  <a:schemeClr val="bg1"/>
+                </a:solidFill>
+                <a:latin typeface="+mj-lt"/>
+                <a:ea typeface="+mj-ea"/>
+                <a:cs typeface="+mj-cs"/>
+              </a:defRPr>
+            </a:lvl1pPr>
+          </a:lstStyle>
+          <a:p>
+            <a:pPr marL="342900" indent="-342900">
+              <a:buFont typeface="Wingdings" panose="05000000000000000000" pitchFamily="2" charset="2"/>
+              <a:buChar char="v"/>
+            </a:pPr>
+            <a:r>
+              <a:rPr lang="en-US" sz="2000" dirty="0"/>
+              <a:t>Repo</a:t>
+            </a:r>
           </a:p>
         </p:txBody>
       </p:sp>
@@ -14665,26 +14980,6 @@
 </file>
 
 <file path=customXml/item1.xml><?xml version="1.0" encoding="utf-8"?>
-<p:properties xmlns:p="http://schemas.microsoft.com/office/2006/metadata/properties" xmlns:xsi="http://www.w3.org/2001/XMLSchema-instance" xmlns:pc="http://schemas.microsoft.com/office/infopath/2007/PartnerControls">
-  <documentManagement>
-    <_ip_UnifiedCompliancePolicyUIAction xmlns="http://schemas.microsoft.com/sharepoint/v3" xsi:nil="true"/>
-    <Image xmlns="71af3243-3dd4-4a8d-8c0d-dd76da1f02a5">
-      <Url xsi:nil="true"/>
-      <Description xsi:nil="true"/>
-    </Image>
-    <Status xmlns="71af3243-3dd4-4a8d-8c0d-dd76da1f02a5">Not started</Status>
-    <Background xmlns="71af3243-3dd4-4a8d-8c0d-dd76da1f02a5">false</Background>
-    <_ip_UnifiedCompliancePolicyProperties xmlns="http://schemas.microsoft.com/sharepoint/v3" xsi:nil="true"/>
-    <ImageTagsTaxHTField xmlns="71af3243-3dd4-4a8d-8c0d-dd76da1f02a5">
-      <Terms xmlns="http://schemas.microsoft.com/office/infopath/2007/PartnerControls"/>
-    </ImageTagsTaxHTField>
-    <TaxCatchAll xmlns="230e9df3-be65-4c73-a93b-d1236ebd677e" xsi:nil="true"/>
-    <MediaServiceKeyPoints xmlns="71af3243-3dd4-4a8d-8c0d-dd76da1f02a5" xsi:nil="true"/>
-  </documentManagement>
-</p:properties>
-</file>
-
-<file path=customXml/item2.xml><?xml version="1.0" encoding="utf-8"?>
 <ct:contentTypeSchema xmlns:ct="http://schemas.microsoft.com/office/2006/metadata/contentType" xmlns:ma="http://schemas.microsoft.com/office/2006/metadata/properties/metaAttributes" ct:_="" ma:_="" ma:contentTypeName="Document" ma:contentTypeID="0x01010079F111ED35F8CC479449609E8A0923A6" ma:contentTypeVersion="30" ma:contentTypeDescription="Create a new document." ma:contentTypeScope="" ma:versionID="cec0622158e8f13124e9e8fd4de31bd1">
   <xsd:schema xmlns:xsd="http://www.w3.org/2001/XMLSchema" xmlns:xs="http://www.w3.org/2001/XMLSchema" xmlns:p="http://schemas.microsoft.com/office/2006/metadata/properties" xmlns:ns1="http://schemas.microsoft.com/sharepoint/v3" xmlns:ns2="71af3243-3dd4-4a8d-8c0d-dd76da1f02a5" xmlns:ns3="16c05727-aa75-4e4a-9b5f-8a80a1165891" xmlns:ns4="230e9df3-be65-4c73-a93b-d1236ebd677e" targetNamespace="http://schemas.microsoft.com/office/2006/metadata/properties" ma:root="true" ma:fieldsID="3b52f30ab005d15df08657af532e6e38" ns1:_="" ns2:_="" ns3:_="" ns4:_="">
     <xsd:import namespace="http://schemas.microsoft.com/sharepoint/v3"/>
@@ -15002,6 +15297,26 @@
 </ct:contentTypeSchema>
 </file>
 
+<file path=customXml/item2.xml><?xml version="1.0" encoding="utf-8"?>
+<p:properties xmlns:p="http://schemas.microsoft.com/office/2006/metadata/properties" xmlns:xsi="http://www.w3.org/2001/XMLSchema-instance" xmlns:pc="http://schemas.microsoft.com/office/infopath/2007/PartnerControls">
+  <documentManagement>
+    <_ip_UnifiedCompliancePolicyUIAction xmlns="http://schemas.microsoft.com/sharepoint/v3" xsi:nil="true"/>
+    <Image xmlns="71af3243-3dd4-4a8d-8c0d-dd76da1f02a5">
+      <Url xsi:nil="true"/>
+      <Description xsi:nil="true"/>
+    </Image>
+    <Status xmlns="71af3243-3dd4-4a8d-8c0d-dd76da1f02a5">Not started</Status>
+    <Background xmlns="71af3243-3dd4-4a8d-8c0d-dd76da1f02a5">false</Background>
+    <_ip_UnifiedCompliancePolicyProperties xmlns="http://schemas.microsoft.com/sharepoint/v3" xsi:nil="true"/>
+    <ImageTagsTaxHTField xmlns="71af3243-3dd4-4a8d-8c0d-dd76da1f02a5">
+      <Terms xmlns="http://schemas.microsoft.com/office/infopath/2007/PartnerControls"/>
+    </ImageTagsTaxHTField>
+    <TaxCatchAll xmlns="230e9df3-be65-4c73-a93b-d1236ebd677e" xsi:nil="true"/>
+    <MediaServiceKeyPoints xmlns="71af3243-3dd4-4a8d-8c0d-dd76da1f02a5" xsi:nil="true"/>
+  </documentManagement>
+</p:properties>
+</file>
+
 <file path=customXml/item3.xml><?xml version="1.0" encoding="utf-8"?>
 <?mso-contentType ?>
 <FormTemplates xmlns="http://schemas.microsoft.com/sharepoint/v3/contenttype/forms">
@@ -15012,18 +15327,6 @@
 </file>
 
 <file path=customXml/itemProps1.xml><?xml version="1.0" encoding="utf-8"?>
-<ds:datastoreItem xmlns:ds="http://schemas.openxmlformats.org/officeDocument/2006/customXml" ds:itemID="{C8DB3C62-858A-4A01-AFEF-21E0BB8CE262}">
-  <ds:schemaRefs>
-    <ds:schemaRef ds:uri="http://schemas.microsoft.com/office/2006/metadata/properties"/>
-    <ds:schemaRef ds:uri="http://schemas.microsoft.com/office/infopath/2007/PartnerControls"/>
-    <ds:schemaRef ds:uri="http://schemas.microsoft.com/sharepoint/v3"/>
-    <ds:schemaRef ds:uri="71af3243-3dd4-4a8d-8c0d-dd76da1f02a5"/>
-    <ds:schemaRef ds:uri="230e9df3-be65-4c73-a93b-d1236ebd677e"/>
-  </ds:schemaRefs>
-</ds:datastoreItem>
-</file>
-
-<file path=customXml/itemProps2.xml><?xml version="1.0" encoding="utf-8"?>
 <ds:datastoreItem xmlns:ds="http://schemas.openxmlformats.org/officeDocument/2006/customXml" ds:itemID="{79897CAE-455D-42C9-A951-0C21BC122543}">
   <ds:schemaRefs>
     <ds:schemaRef ds:uri="http://schemas.microsoft.com/office/2006/metadata/contentType"/>
@@ -15044,6 +15347,18 @@
 </ds:datastoreItem>
 </file>
 
+<file path=customXml/itemProps2.xml><?xml version="1.0" encoding="utf-8"?>
+<ds:datastoreItem xmlns:ds="http://schemas.openxmlformats.org/officeDocument/2006/customXml" ds:itemID="{C8DB3C62-858A-4A01-AFEF-21E0BB8CE262}">
+  <ds:schemaRefs>
+    <ds:schemaRef ds:uri="http://schemas.microsoft.com/office/2006/metadata/properties"/>
+    <ds:schemaRef ds:uri="http://schemas.microsoft.com/office/infopath/2007/PartnerControls"/>
+    <ds:schemaRef ds:uri="http://schemas.microsoft.com/sharepoint/v3"/>
+    <ds:schemaRef ds:uri="71af3243-3dd4-4a8d-8c0d-dd76da1f02a5"/>
+    <ds:schemaRef ds:uri="230e9df3-be65-4c73-a93b-d1236ebd677e"/>
+  </ds:schemaRefs>
+</ds:datastoreItem>
+</file>
+
 <file path=customXml/itemProps3.xml><?xml version="1.0" encoding="utf-8"?>
 <ds:datastoreItem xmlns:ds="http://schemas.openxmlformats.org/officeDocument/2006/customXml" ds:itemID="{B0009351-EDD4-484E-ACD6-D50CCB137637}">
   <ds:schemaRefs>

</xml_diff>